<commit_message>
Slides: count the default rollout cards correctly (sd-13-017), keep the 'some plugins' qualifier (sd-13-010)
Co-Authored-By: Claude Sonnet 5.5 <noreply@anthropic.com>
Claude-Session: https://claude.ai/code/session_01EhxTYrCJpuk4mcqCLwPdds
</commit_message>
<xml_diff>
--- a/system-design-101/vi/lessons/sd-13-010/slides/sd-13-010.pptx
+++ b/system-design-101/vi/lessons/sd-13-010/slides/sd-13-010.pptx
@@ -5930,7 +5930,7 @@
               <a:buNone/>
             </a:pPr>
             <a:r>
-              <a:rPr lang="en-US" sz="2100" dirty="0" spc="-2" kern="0">
+              <a:rPr lang="en-US" sz="2100" dirty="0" spc="-8" kern="0">
                 <a:solidFill>
                   <a:srgbClr val="6B6A66"/>
                 </a:solidFill>
@@ -5938,7 +5938,18 @@
                 <a:ea typeface="Be Vietnam Pro" pitchFamily="34" charset="-122"/>
                 <a:cs typeface="Be Vietnam Pro" pitchFamily="34" charset="-120"/>
               </a:rPr>
-              <a:t>Có</a:t>
+              <a:t>Một</a:t>
+            </a:r>
+            <a:r>
+              <a:rPr lang="en-US" sz="2100" dirty="0" spc="-9" kern="0">
+                <a:solidFill>
+                  <a:srgbClr val="6B6A66"/>
+                </a:solidFill>
+                <a:latin typeface="Be Vietnam Pro" pitchFamily="34" charset="0"/>
+                <a:ea typeface="Be Vietnam Pro" pitchFamily="34" charset="-122"/>
+                <a:cs typeface="Be Vietnam Pro" pitchFamily="34" charset="-120"/>
+              </a:rPr>
+              <a:t> số</a:t>
             </a:r>
             <a:r>
               <a:rPr lang="en-US" sz="2100" dirty="0" spc="0" kern="0">
@@ -5949,6 +5960,28 @@
                 <a:ea typeface="Be Vietnam Pro" pitchFamily="34" charset="-122"/>
                 <a:cs typeface="Be Vietnam Pro" pitchFamily="34" charset="-120"/>
               </a:rPr>
+              <a:t> plugin</a:t>
+            </a:r>
+            <a:r>
+              <a:rPr lang="en-US" sz="2100" dirty="0" spc="-5" kern="0">
+                <a:solidFill>
+                  <a:srgbClr val="6B6A66"/>
+                </a:solidFill>
+                <a:latin typeface="Be Vietnam Pro" pitchFamily="34" charset="0"/>
+                <a:ea typeface="Be Vietnam Pro" pitchFamily="34" charset="-122"/>
+                <a:cs typeface="Be Vietnam Pro" pitchFamily="34" charset="-120"/>
+              </a:rPr>
+              <a:t> có</a:t>
+            </a:r>
+            <a:r>
+              <a:rPr lang="en-US" sz="2100" dirty="0" spc="0" kern="0">
+                <a:solidFill>
+                  <a:srgbClr val="6B6A66"/>
+                </a:solidFill>
+                <a:latin typeface="Be Vietnam Pro" pitchFamily="34" charset="0"/>
+                <a:ea typeface="Be Vietnam Pro" pitchFamily="34" charset="-122"/>
+                <a:cs typeface="Be Vietnam Pro" pitchFamily="34" charset="-120"/>
+              </a:rPr>
               <a:t> thể</a:t>
             </a:r>
             <a:r>
@@ -5961,17 +5994,6 @@
                 <a:cs typeface="Be Vietnam Pro" pitchFamily="34" charset="-120"/>
               </a:rPr>
               <a:t> thay</a:t>
-            </a:r>
-            <a:r>
-              <a:rPr lang="en-US" sz="2100" dirty="0" spc="-1" kern="0">
-                <a:solidFill>
-                  <a:srgbClr val="6B6A66"/>
-                </a:solidFill>
-                <a:latin typeface="Be Vietnam Pro" pitchFamily="34" charset="0"/>
-                <a:ea typeface="Be Vietnam Pro" pitchFamily="34" charset="-122"/>
-                <a:cs typeface="Be Vietnam Pro" pitchFamily="34" charset="-120"/>
-              </a:rPr>
-              <a:t> thế</a:t>
             </a:r>
             <a:r>
               <a:rPr lang="en-US" sz="2100" dirty="0" spc="-16" kern="0">

</xml_diff>

<commit_message>
Slides: use only what the lesson names (sd-13-010), say minReadySeconds is a configured duration (sd-13-017)
Co-Authored-By: Claude Sonnet 5.5 <noreply@anthropic.com>
Claude-Session: https://claude.ai/code/session_01EhxTYrCJpuk4mcqCLwPdds
</commit_message>
<xml_diff>
--- a/system-design-101/vi/lessons/sd-13-010/slides/sd-13-010.pptx
+++ b/system-design-101/vi/lessons/sd-13-010/slides/sd-13-010.pptx
@@ -4727,7 +4727,7 @@
         <p:spPr>
           <a:xfrm>
             <a:off x="914400" y="5524500"/>
-            <a:ext cx="5143500" cy="952500"/>
+            <a:ext cx="8096250" cy="952500"/>
           </a:xfrm>
           <a:prstGeom prst="roundRect">
             <a:avLst>
@@ -4752,7 +4752,7 @@
               <a:buNone/>
             </a:pPr>
             <a:r>
-              <a:rPr lang="en-US" sz="2550" b="1" dirty="0" spc="-5" kern="0">
+              <a:rPr lang="en-US" sz="2550" b="1" dirty="0" spc="2" kern="0">
                 <a:solidFill>
                   <a:srgbClr val="3DD6A0"/>
                 </a:solidFill>
@@ -4760,7 +4760,29 @@
                 <a:ea typeface="Be Vietnam Pro" pitchFamily="34" charset="-122"/>
                 <a:cs typeface="Be Vietnam Pro" pitchFamily="34" charset="-120"/>
               </a:rPr>
-              <a:t>kube-apiserver</a:t>
+              <a:t>Đi</a:t>
+            </a:r>
+            <a:r>
+              <a:rPr lang="en-US" sz="2550" b="1" dirty="0" spc="-29" kern="0">
+                <a:solidFill>
+                  <a:srgbClr val="3DD6A0"/>
+                </a:solidFill>
+                <a:latin typeface="Be Vietnam Pro" pitchFamily="34" charset="0"/>
+                <a:ea typeface="Be Vietnam Pro" pitchFamily="34" charset="-122"/>
+                <a:cs typeface="Be Vietnam Pro" pitchFamily="34" charset="-120"/>
+              </a:rPr>
+              <a:t> kèm</a:t>
+            </a:r>
+            <a:r>
+              <a:rPr lang="en-US" sz="2550" b="1" dirty="0" spc="-1" kern="0">
+                <a:solidFill>
+                  <a:srgbClr val="3DD6A0"/>
+                </a:solidFill>
+                <a:latin typeface="Be Vietnam Pro" pitchFamily="34" charset="0"/>
+                <a:ea typeface="Be Vietnam Pro" pitchFamily="34" charset="-122"/>
+                <a:cs typeface="Be Vietnam Pro" pitchFamily="34" charset="-120"/>
+              </a:rPr>
+              <a:t> cụm</a:t>
             </a:r>
             <a:endParaRPr lang="en-US" sz="2550" dirty="0"/>
           </a:p>
@@ -4774,8 +4796,8 @@
         </p:nvSpPr>
         <p:spPr>
           <a:xfrm>
-            <a:off x="6343650" y="5524500"/>
-            <a:ext cx="5143500" cy="952500"/>
+            <a:off x="9277350" y="5524500"/>
+            <a:ext cx="8096250" cy="952500"/>
           </a:xfrm>
           <a:prstGeom prst="roundRect">
             <a:avLst>
@@ -4800,7 +4822,7 @@
               <a:buNone/>
             </a:pPr>
             <a:r>
-              <a:rPr lang="en-US" sz="2550" b="1" dirty="0" spc="-12" kern="0">
+              <a:rPr lang="en-US" sz="2550" b="1" dirty="0" spc="-7" kern="0">
                 <a:solidFill>
                   <a:srgbClr val="3DD6A0"/>
                 </a:solidFill>
@@ -4808,7 +4830,40 @@
                 <a:ea typeface="Be Vietnam Pro" pitchFamily="34" charset="-122"/>
                 <a:cs typeface="Be Vietnam Pro" pitchFamily="34" charset="-120"/>
               </a:rPr>
-              <a:t>etcd</a:t>
+              <a:t>Không</a:t>
+            </a:r>
+            <a:r>
+              <a:rPr lang="en-US" sz="2550" b="1" dirty="0" spc="-3" kern="0">
+                <a:solidFill>
+                  <a:srgbClr val="3DD6A0"/>
+                </a:solidFill>
+                <a:latin typeface="Be Vietnam Pro" pitchFamily="34" charset="0"/>
+                <a:ea typeface="Be Vietnam Pro" pitchFamily="34" charset="-122"/>
+                <a:cs typeface="Be Vietnam Pro" pitchFamily="34" charset="-120"/>
+              </a:rPr>
+              <a:t> phải</a:t>
+            </a:r>
+            <a:r>
+              <a:rPr lang="en-US" sz="2550" b="1" dirty="0" spc="0" kern="0">
+                <a:solidFill>
+                  <a:srgbClr val="3DD6A0"/>
+                </a:solidFill>
+                <a:latin typeface="Be Vietnam Pro" pitchFamily="34" charset="0"/>
+                <a:ea typeface="Be Vietnam Pro" pitchFamily="34" charset="-122"/>
+                <a:cs typeface="Be Vietnam Pro" pitchFamily="34" charset="-120"/>
+              </a:rPr>
+              <a:t> tự</a:t>
+            </a:r>
+            <a:r>
+              <a:rPr lang="en-US" sz="2550" b="1" dirty="0" spc="1" kern="0">
+                <a:solidFill>
+                  <a:srgbClr val="3DD6A0"/>
+                </a:solidFill>
+                <a:latin typeface="Be Vietnam Pro" pitchFamily="34" charset="0"/>
+                <a:ea typeface="Be Vietnam Pro" pitchFamily="34" charset="-122"/>
+                <a:cs typeface="Be Vietnam Pro" pitchFamily="34" charset="-120"/>
+              </a:rPr>
+              <a:t> cài</a:t>
             </a:r>
             <a:endParaRPr lang="en-US" sz="2550" dirty="0"/>
           </a:p>
@@ -4816,221 +4871,7 @@
       </p:sp>
       <p:sp>
         <p:nvSpPr>
-          <p:cNvPr id="7" name="Text 5"/>
-          <p:cNvSpPr/>
-          <p:nvPr/>
-        </p:nvSpPr>
-        <p:spPr>
-          <a:xfrm>
-            <a:off x="11772900" y="5524500"/>
-            <a:ext cx="5143500" cy="952500"/>
-          </a:xfrm>
-          <a:prstGeom prst="roundRect">
-            <a:avLst>
-              <a:gd name="adj" fmla="val 50000"/>
-            </a:avLst>
-          </a:prstGeom>
-          <a:solidFill>
-            <a:srgbClr val="1E212B"/>
-          </a:solidFill>
-          <a:ln w="28575">
-            <a:solidFill>
-              <a:srgbClr val="3DD6A0"/>
-            </a:solidFill>
-            <a:prstDash val="solid"/>
-          </a:ln>
-        </p:spPr>
-        <p:txBody>
-          <a:bodyPr wrap="square" lIns="0" tIns="0" rIns="0" bIns="0" rtlCol="0" anchor="ctr"/>
-          <a:lstStyle/>
-          <a:p>
-            <a:pPr algn="ctr" indent="0" marL="0">
-              <a:buNone/>
-            </a:pPr>
-            <a:r>
-              <a:rPr lang="en-US" sz="2550" b="1" dirty="0" spc="-7" kern="0">
-                <a:solidFill>
-                  <a:srgbClr val="3DD6A0"/>
-                </a:solidFill>
-                <a:latin typeface="Be Vietnam Pro" pitchFamily="34" charset="0"/>
-                <a:ea typeface="Be Vietnam Pro" pitchFamily="34" charset="-122"/>
-                <a:cs typeface="Be Vietnam Pro" pitchFamily="34" charset="-120"/>
-              </a:rPr>
-              <a:t>scheduler</a:t>
-            </a:r>
-            <a:endParaRPr lang="en-US" sz="2550" dirty="0"/>
-          </a:p>
-        </p:txBody>
-      </p:sp>
-      <p:sp>
-        <p:nvSpPr>
-          <p:cNvPr id="8" name="Text 6"/>
-          <p:cNvSpPr/>
-          <p:nvPr/>
-        </p:nvSpPr>
-        <p:spPr>
-          <a:xfrm>
-            <a:off x="914400" y="6762750"/>
-            <a:ext cx="5143500" cy="952500"/>
-          </a:xfrm>
-          <a:prstGeom prst="roundRect">
-            <a:avLst>
-              <a:gd name="adj" fmla="val 50000"/>
-            </a:avLst>
-          </a:prstGeom>
-          <a:solidFill>
-            <a:srgbClr val="1E212B"/>
-          </a:solidFill>
-          <a:ln w="28575">
-            <a:solidFill>
-              <a:srgbClr val="3DD6A0"/>
-            </a:solidFill>
-            <a:prstDash val="solid"/>
-          </a:ln>
-        </p:spPr>
-        <p:txBody>
-          <a:bodyPr wrap="square" lIns="0" tIns="0" rIns="0" bIns="0" rtlCol="0" anchor="ctr"/>
-          <a:lstStyle/>
-          <a:p>
-            <a:pPr algn="ctr" indent="0" marL="0">
-              <a:buNone/>
-            </a:pPr>
-            <a:r>
-              <a:rPr lang="en-US" sz="2550" b="1" dirty="0" spc="-14" kern="0">
-                <a:solidFill>
-                  <a:srgbClr val="3DD6A0"/>
-                </a:solidFill>
-                <a:latin typeface="Be Vietnam Pro" pitchFamily="34" charset="0"/>
-                <a:ea typeface="Be Vietnam Pro" pitchFamily="34" charset="-122"/>
-                <a:cs typeface="Be Vietnam Pro" pitchFamily="34" charset="-120"/>
-              </a:rPr>
-              <a:t>controller</a:t>
-            </a:r>
-            <a:r>
-              <a:rPr lang="en-US" sz="2550" b="1" dirty="0" spc="-3" kern="0">
-                <a:solidFill>
-                  <a:srgbClr val="3DD6A0"/>
-                </a:solidFill>
-                <a:latin typeface="Be Vietnam Pro" pitchFamily="34" charset="0"/>
-                <a:ea typeface="Be Vietnam Pro" pitchFamily="34" charset="-122"/>
-                <a:cs typeface="Be Vietnam Pro" pitchFamily="34" charset="-120"/>
-              </a:rPr>
-              <a:t> manager</a:t>
-            </a:r>
-            <a:endParaRPr lang="en-US" sz="2550" dirty="0"/>
-          </a:p>
-        </p:txBody>
-      </p:sp>
-      <p:sp>
-        <p:nvSpPr>
-          <p:cNvPr id="9" name="Text 7"/>
-          <p:cNvSpPr/>
-          <p:nvPr/>
-        </p:nvSpPr>
-        <p:spPr>
-          <a:xfrm>
-            <a:off x="6343650" y="6762750"/>
-            <a:ext cx="5143500" cy="952500"/>
-          </a:xfrm>
-          <a:prstGeom prst="roundRect">
-            <a:avLst>
-              <a:gd name="adj" fmla="val 50000"/>
-            </a:avLst>
-          </a:prstGeom>
-          <a:solidFill>
-            <a:srgbClr val="1E212B"/>
-          </a:solidFill>
-          <a:ln w="28575">
-            <a:solidFill>
-              <a:srgbClr val="3DD6A0"/>
-            </a:solidFill>
-            <a:prstDash val="solid"/>
-          </a:ln>
-        </p:spPr>
-        <p:txBody>
-          <a:bodyPr wrap="square" lIns="0" tIns="0" rIns="0" bIns="0" rtlCol="0" anchor="ctr"/>
-          <a:lstStyle/>
-          <a:p>
-            <a:pPr algn="ctr" indent="0" marL="0">
-              <a:buNone/>
-            </a:pPr>
-            <a:r>
-              <a:rPr lang="en-US" sz="2550" b="1" dirty="0" spc="-9" kern="0">
-                <a:solidFill>
-                  <a:srgbClr val="3DD6A0"/>
-                </a:solidFill>
-                <a:latin typeface="Be Vietnam Pro" pitchFamily="34" charset="0"/>
-                <a:ea typeface="Be Vietnam Pro" pitchFamily="34" charset="-122"/>
-                <a:cs typeface="Be Vietnam Pro" pitchFamily="34" charset="-120"/>
-              </a:rPr>
-              <a:t>kubelet</a:t>
-            </a:r>
-            <a:endParaRPr lang="en-US" sz="2550" dirty="0"/>
-          </a:p>
-        </p:txBody>
-      </p:sp>
-      <p:sp>
-        <p:nvSpPr>
-          <p:cNvPr id="10" name="Text 8"/>
-          <p:cNvSpPr/>
-          <p:nvPr/>
-        </p:nvSpPr>
-        <p:spPr>
-          <a:xfrm>
-            <a:off x="11772900" y="6762750"/>
-            <a:ext cx="5143500" cy="952500"/>
-          </a:xfrm>
-          <a:prstGeom prst="roundRect">
-            <a:avLst>
-              <a:gd name="adj" fmla="val 50000"/>
-            </a:avLst>
-          </a:prstGeom>
-          <a:solidFill>
-            <a:srgbClr val="1E212B"/>
-          </a:solidFill>
-          <a:ln w="28575">
-            <a:solidFill>
-              <a:srgbClr val="3DD6A0"/>
-            </a:solidFill>
-            <a:prstDash val="solid"/>
-          </a:ln>
-        </p:spPr>
-        <p:txBody>
-          <a:bodyPr wrap="square" lIns="0" tIns="0" rIns="0" bIns="0" rtlCol="0" anchor="ctr"/>
-          <a:lstStyle/>
-          <a:p>
-            <a:pPr algn="ctr" indent="0" marL="0">
-              <a:buNone/>
-            </a:pPr>
-            <a:r>
-              <a:rPr lang="en-US" sz="2550" b="1" dirty="0" spc="-7" kern="0">
-                <a:solidFill>
-                  <a:srgbClr val="3DD6A0"/>
-                </a:solidFill>
-                <a:latin typeface="Be Vietnam Pro" pitchFamily="34" charset="0"/>
-                <a:ea typeface="Be Vietnam Pro" pitchFamily="34" charset="-122"/>
-                <a:cs typeface="Be Vietnam Pro" pitchFamily="34" charset="-120"/>
-              </a:rPr>
-              <a:t>container</a:t>
-            </a:r>
-            <a:r>
-              <a:rPr lang="en-US" sz="2550" b="1" dirty="0" spc="-5" kern="0">
-                <a:solidFill>
-                  <a:srgbClr val="3DD6A0"/>
-                </a:solidFill>
-                <a:latin typeface="Be Vietnam Pro" pitchFamily="34" charset="0"/>
-                <a:ea typeface="Be Vietnam Pro" pitchFamily="34" charset="-122"/>
-                <a:cs typeface="Be Vietnam Pro" pitchFamily="34" charset="-120"/>
-              </a:rPr>
-              <a:t> runtime</a:t>
-            </a:r>
-            <a:endParaRPr lang="en-US" sz="2550" dirty="0"/>
-          </a:p>
-        </p:txBody>
-      </p:sp>
-      <p:sp>
-        <p:nvSpPr>
-          <p:cNvPr id="11" name="Shape 9"/>
+          <p:cNvPr id="7" name="Shape 5"/>
           <p:cNvSpPr/>
           <p:nvPr/>
         </p:nvSpPr>
@@ -5050,7 +4891,7 @@
       </p:sp>
       <p:sp>
         <p:nvSpPr>
-          <p:cNvPr id="12" name="Shape 10"/>
+          <p:cNvPr id="8" name="Shape 6"/>
           <p:cNvSpPr/>
           <p:nvPr/>
         </p:nvSpPr>
@@ -5070,7 +4911,7 @@
       </p:sp>
       <p:sp>
         <p:nvSpPr>
-          <p:cNvPr id="13" name="Shape 11"/>
+          <p:cNvPr id="9" name="Shape 7"/>
           <p:cNvSpPr/>
           <p:nvPr/>
         </p:nvSpPr>
@@ -5090,7 +4931,7 @@
       </p:sp>
       <p:sp>
         <p:nvSpPr>
-          <p:cNvPr id="14" name="Shape 12"/>
+          <p:cNvPr id="10" name="Shape 8"/>
           <p:cNvSpPr/>
           <p:nvPr/>
         </p:nvSpPr>
@@ -5110,7 +4951,7 @@
       </p:sp>
       <p:sp>
         <p:nvSpPr>
-          <p:cNvPr id="15" name="Shape 13"/>
+          <p:cNvPr id="11" name="Shape 9"/>
           <p:cNvSpPr/>
           <p:nvPr/>
         </p:nvSpPr>
@@ -5130,7 +4971,7 @@
       </p:sp>
       <p:sp>
         <p:nvSpPr>
-          <p:cNvPr id="16" name="Shape 14"/>
+          <p:cNvPr id="12" name="Shape 10"/>
           <p:cNvSpPr/>
           <p:nvPr/>
         </p:nvSpPr>
@@ -5150,7 +4991,7 @@
       </p:sp>
       <p:sp>
         <p:nvSpPr>
-          <p:cNvPr id="17" name="Shape 15"/>
+          <p:cNvPr id="13" name="Shape 11"/>
           <p:cNvSpPr/>
           <p:nvPr/>
         </p:nvSpPr>
@@ -5170,7 +5011,7 @@
       </p:sp>
       <p:sp>
         <p:nvSpPr>
-          <p:cNvPr id="18" name="Shape 16"/>
+          <p:cNvPr id="14" name="Shape 12"/>
           <p:cNvSpPr/>
           <p:nvPr/>
         </p:nvSpPr>
@@ -5190,7 +5031,7 @@
       </p:sp>
       <p:sp>
         <p:nvSpPr>
-          <p:cNvPr id="19" name="Shape 17"/>
+          <p:cNvPr id="15" name="Shape 13"/>
           <p:cNvSpPr/>
           <p:nvPr/>
         </p:nvSpPr>
@@ -5210,7 +5051,7 @@
       </p:sp>
       <p:sp>
         <p:nvSpPr>
-          <p:cNvPr id="20" name="Shape 18"/>
+          <p:cNvPr id="16" name="Shape 14"/>
           <p:cNvSpPr/>
           <p:nvPr/>
         </p:nvSpPr>
@@ -5230,7 +5071,7 @@
       </p:sp>
       <p:sp>
         <p:nvSpPr>
-          <p:cNvPr id="21" name="Text 19"/>
+          <p:cNvPr id="17" name="Text 15"/>
           <p:cNvSpPr/>
           <p:nvPr/>
         </p:nvSpPr>
@@ -5346,7 +5187,7 @@
       </p:sp>
       <p:sp>
         <p:nvSpPr>
-          <p:cNvPr id="22" name="Shape 20"/>
+          <p:cNvPr id="18" name="Shape 16"/>
           <p:cNvSpPr/>
           <p:nvPr/>
         </p:nvSpPr>
@@ -5370,7 +5211,7 @@
       </p:sp>
       <p:pic>
         <p:nvPicPr>
-          <p:cNvPr id="23" name="Moda image moda-export-watermark-361851f1-2b38-4d16-a24c-411e82a77c5c" descr="">    </p:cNvPr>
+          <p:cNvPr id="19" name="Moda image moda-export-watermark-361851f1-2b38-4d16-a24c-411e82a77c5c" descr="">    </p:cNvPr>
           <p:cNvPicPr>
             <a:picLocks noChangeAspect="1"/>
           </p:cNvPicPr>
@@ -7818,7 +7659,7 @@
         <p:spPr>
           <a:xfrm>
             <a:off x="1295400" y="3810000"/>
-            <a:ext cx="4762500" cy="1143000"/>
+            <a:ext cx="15697200" cy="1143000"/>
           </a:xfrm>
           <a:prstGeom prst="roundRect">
             <a:avLst>
@@ -7865,23 +7706,18 @@
         </p:nvSpPr>
         <p:spPr>
           <a:xfrm>
-            <a:off x="6762750" y="3810000"/>
-            <a:ext cx="4762500" cy="1143000"/>
+            <a:off x="914400" y="5905500"/>
+            <a:ext cx="16459200" cy="1905000"/>
           </a:xfrm>
           <a:prstGeom prst="roundRect">
             <a:avLst>
-              <a:gd name="adj" fmla="val 50000"/>
+              <a:gd name="adj" fmla="val 14000"/>
             </a:avLst>
           </a:prstGeom>
           <a:solidFill>
-            <a:srgbClr val="14161C"/>
-          </a:solidFill>
-          <a:ln w="28575">
-            <a:solidFill>
-              <a:srgbClr val="FFB454"/>
-            </a:solidFill>
-            <a:prstDash val="solid"/>
-          </a:ln>
+            <a:srgbClr val="2A2E3B"/>
+          </a:solidFill>
+          <a:ln/>
         </p:spPr>
         <p:txBody>
           <a:bodyPr wrap="square" lIns="0" tIns="0" rIns="0" bIns="0" rtlCol="0" anchor="ctr"/>
@@ -7891,97 +7727,6 @@
               <a:buNone/>
             </a:pPr>
             <a:r>
-              <a:rPr lang="en-US" sz="3000" dirty="0" spc="-16" kern="0">
-                <a:solidFill>
-                  <a:srgbClr val="FFB454"/>
-                </a:solidFill>
-                <a:latin typeface="Be Vietnam Pro ExtraBold" pitchFamily="34" charset="0"/>
-                <a:ea typeface="Be Vietnam Pro ExtraBold" pitchFamily="34" charset="-122"/>
-                <a:cs typeface="Be Vietnam Pro ExtraBold" pitchFamily="34" charset="-120"/>
-              </a:rPr>
-              <a:t>Prometheus</a:t>
-            </a:r>
-            <a:endParaRPr lang="en-US" sz="3000" dirty="0"/>
-          </a:p>
-        </p:txBody>
-      </p:sp>
-      <p:sp>
-        <p:nvSpPr>
-          <p:cNvPr id="8" name="Text 6"/>
-          <p:cNvSpPr/>
-          <p:nvPr/>
-        </p:nvSpPr>
-        <p:spPr>
-          <a:xfrm>
-            <a:off x="12230100" y="3810000"/>
-            <a:ext cx="4762500" cy="1143000"/>
-          </a:xfrm>
-          <a:prstGeom prst="roundRect">
-            <a:avLst>
-              <a:gd name="adj" fmla="val 50000"/>
-            </a:avLst>
-          </a:prstGeom>
-          <a:solidFill>
-            <a:srgbClr val="14161C"/>
-          </a:solidFill>
-          <a:ln w="28575">
-            <a:solidFill>
-              <a:srgbClr val="FFB454"/>
-            </a:solidFill>
-            <a:prstDash val="solid"/>
-          </a:ln>
-        </p:spPr>
-        <p:txBody>
-          <a:bodyPr wrap="square" lIns="0" tIns="0" rIns="0" bIns="0" rtlCol="0" anchor="ctr"/>
-          <a:lstStyle/>
-          <a:p>
-            <a:pPr algn="ctr" indent="0" marL="0">
-              <a:buNone/>
-            </a:pPr>
-            <a:r>
-              <a:rPr lang="en-US" sz="3000" dirty="0" spc="-27" kern="0">
-                <a:solidFill>
-                  <a:srgbClr val="FFB454"/>
-                </a:solidFill>
-                <a:latin typeface="Be Vietnam Pro ExtraBold" pitchFamily="34" charset="0"/>
-                <a:ea typeface="Be Vietnam Pro ExtraBold" pitchFamily="34" charset="-122"/>
-                <a:cs typeface="Be Vietnam Pro ExtraBold" pitchFamily="34" charset="-120"/>
-              </a:rPr>
-              <a:t>Istio...</a:t>
-            </a:r>
-            <a:endParaRPr lang="en-US" sz="3000" dirty="0"/>
-          </a:p>
-        </p:txBody>
-      </p:sp>
-      <p:sp>
-        <p:nvSpPr>
-          <p:cNvPr id="9" name="Text 7"/>
-          <p:cNvSpPr/>
-          <p:nvPr/>
-        </p:nvSpPr>
-        <p:spPr>
-          <a:xfrm>
-            <a:off x="914400" y="5905500"/>
-            <a:ext cx="16459200" cy="1905000"/>
-          </a:xfrm>
-          <a:prstGeom prst="roundRect">
-            <a:avLst>
-              <a:gd name="adj" fmla="val 14000"/>
-            </a:avLst>
-          </a:prstGeom>
-          <a:solidFill>
-            <a:srgbClr val="2A2E3B"/>
-          </a:solidFill>
-          <a:ln/>
-        </p:spPr>
-        <p:txBody>
-          <a:bodyPr wrap="square" lIns="0" tIns="0" rIns="0" bIns="0" rtlCol="0" anchor="ctr"/>
-          <a:lstStyle/>
-          <a:p>
-            <a:pPr algn="ctr" indent="0" marL="0">
-              <a:buNone/>
-            </a:pPr>
-            <a:r>
               <a:rPr lang="en-US" sz="4800" dirty="0" spc="-19" kern="0">
                 <a:solidFill>
                   <a:srgbClr val="F3EEE3"/>
@@ -7998,7 +7743,7 @@
       </p:sp>
       <p:sp>
         <p:nvSpPr>
-          <p:cNvPr id="10" name="Shape 8"/>
+          <p:cNvPr id="8" name="Shape 6"/>
           <p:cNvSpPr/>
           <p:nvPr/>
         </p:nvSpPr>
@@ -8018,7 +7763,7 @@
       </p:sp>
       <p:sp>
         <p:nvSpPr>
-          <p:cNvPr id="11" name="Shape 9"/>
+          <p:cNvPr id="9" name="Shape 7"/>
           <p:cNvSpPr/>
           <p:nvPr/>
         </p:nvSpPr>
@@ -8038,7 +7783,7 @@
       </p:sp>
       <p:sp>
         <p:nvSpPr>
-          <p:cNvPr id="12" name="Shape 10"/>
+          <p:cNvPr id="10" name="Shape 8"/>
           <p:cNvSpPr/>
           <p:nvPr/>
         </p:nvSpPr>
@@ -8058,7 +7803,7 @@
       </p:sp>
       <p:sp>
         <p:nvSpPr>
-          <p:cNvPr id="13" name="Shape 11"/>
+          <p:cNvPr id="11" name="Shape 9"/>
           <p:cNvSpPr/>
           <p:nvPr/>
         </p:nvSpPr>
@@ -8078,7 +7823,7 @@
       </p:sp>
       <p:sp>
         <p:nvSpPr>
-          <p:cNvPr id="14" name="Shape 12"/>
+          <p:cNvPr id="12" name="Shape 10"/>
           <p:cNvSpPr/>
           <p:nvPr/>
         </p:nvSpPr>
@@ -8098,7 +7843,7 @@
       </p:sp>
       <p:sp>
         <p:nvSpPr>
-          <p:cNvPr id="15" name="Shape 13"/>
+          <p:cNvPr id="13" name="Shape 11"/>
           <p:cNvSpPr/>
           <p:nvPr/>
         </p:nvSpPr>
@@ -8118,7 +7863,7 @@
       </p:sp>
       <p:sp>
         <p:nvSpPr>
-          <p:cNvPr id="16" name="Shape 14"/>
+          <p:cNvPr id="14" name="Shape 12"/>
           <p:cNvSpPr/>
           <p:nvPr/>
         </p:nvSpPr>
@@ -8138,7 +7883,7 @@
       </p:sp>
       <p:sp>
         <p:nvSpPr>
-          <p:cNvPr id="17" name="Shape 15"/>
+          <p:cNvPr id="15" name="Shape 13"/>
           <p:cNvSpPr/>
           <p:nvPr/>
         </p:nvSpPr>
@@ -8158,7 +7903,7 @@
       </p:sp>
       <p:sp>
         <p:nvSpPr>
-          <p:cNvPr id="18" name="Shape 16"/>
+          <p:cNvPr id="16" name="Shape 14"/>
           <p:cNvSpPr/>
           <p:nvPr/>
         </p:nvSpPr>
@@ -8178,7 +7923,7 @@
       </p:sp>
       <p:sp>
         <p:nvSpPr>
-          <p:cNvPr id="19" name="Shape 17"/>
+          <p:cNvPr id="17" name="Shape 15"/>
           <p:cNvSpPr/>
           <p:nvPr/>
         </p:nvSpPr>
@@ -8198,7 +7943,7 @@
       </p:sp>
       <p:sp>
         <p:nvSpPr>
-          <p:cNvPr id="20" name="Text 18"/>
+          <p:cNvPr id="18" name="Text 16"/>
           <p:cNvSpPr/>
           <p:nvPr/>
         </p:nvSpPr>
@@ -8314,7 +8059,7 @@
       </p:sp>
       <p:sp>
         <p:nvSpPr>
-          <p:cNvPr id="21" name="Shape 19"/>
+          <p:cNvPr id="19" name="Shape 17"/>
           <p:cNvSpPr/>
           <p:nvPr/>
         </p:nvSpPr>
@@ -8338,7 +8083,7 @@
       </p:sp>
       <p:pic>
         <p:nvPicPr>
-          <p:cNvPr id="22" name="Moda image moda-export-watermark-c30c0116-2c19-41e6-b083-6a41fb634fab" descr="">    </p:cNvPr>
+          <p:cNvPr id="20" name="Moda image moda-export-watermark-c30c0116-2c19-41e6-b083-6a41fb634fab" descr="">    </p:cNvPr>
           <p:cNvPicPr>
             <a:picLocks noChangeAspect="1"/>
           </p:cNvPicPr>

</xml_diff>

<commit_message>
Slides: drop API-object examples the lesson does not give (sd-13-010), keep 'thường' on the handoff claim (sd-13-019)
Co-Authored-By: Claude Sonnet 5.5 <noreply@anthropic.com>
Claude-Session: https://claude.ai/code/session_01EhxTYrCJpuk4mcqCLwPdds
</commit_message>
<xml_diff>
--- a/system-design-101/vi/lessons/sd-13-010/slides/sd-13-010.pptx
+++ b/system-design-101/vi/lessons/sd-13-010/slides/sd-13-010.pptx
@@ -6476,7 +6476,7 @@
         <p:spPr>
           <a:xfrm>
             <a:off x="914400" y="3143250"/>
-            <a:ext cx="5257800" cy="1905000"/>
+            <a:ext cx="8001000" cy="1905000"/>
           </a:xfrm>
           <a:prstGeom prst="roundRect">
             <a:avLst>
@@ -6502,8 +6502,8 @@
         </p:nvSpPr>
         <p:spPr>
           <a:xfrm>
-            <a:off x="6515100" y="3143250"/>
-            <a:ext cx="5257800" cy="1905000"/>
+            <a:off x="9372600" y="3143250"/>
+            <a:ext cx="8001000" cy="1905000"/>
           </a:xfrm>
           <a:prstGeom prst="roundRect">
             <a:avLst>
@@ -6523,122 +6523,14 @@
       </p:sp>
       <p:sp>
         <p:nvSpPr>
-          <p:cNvPr id="6" name="Shape 4"/>
-          <p:cNvSpPr/>
-          <p:nvPr/>
-        </p:nvSpPr>
-        <p:spPr>
-          <a:xfrm>
-            <a:off x="12115800" y="3143250"/>
-            <a:ext cx="5257800" cy="1905000"/>
-          </a:xfrm>
-          <a:prstGeom prst="roundRect">
-            <a:avLst>
-              <a:gd name="adj" fmla="val 14000"/>
-            </a:avLst>
-          </a:prstGeom>
-          <a:solidFill>
-            <a:srgbClr val="DDE3FA"/>
-          </a:solidFill>
-          <a:ln w="28575">
-            <a:solidFill>
-              <a:srgbClr val="1F3FD1"/>
-            </a:solidFill>
-            <a:prstDash val="solid"/>
-          </a:ln>
-        </p:spPr>
-      </p:sp>
-      <p:sp>
-        <p:nvSpPr>
-          <p:cNvPr id="7" name="Shape 5"/>
-          <p:cNvSpPr/>
-          <p:nvPr/>
-        </p:nvSpPr>
-        <p:spPr>
-          <a:xfrm>
-            <a:off x="914400" y="5429250"/>
-            <a:ext cx="5257800" cy="1905000"/>
-          </a:xfrm>
-          <a:prstGeom prst="roundRect">
-            <a:avLst>
-              <a:gd name="adj" fmla="val 14000"/>
-            </a:avLst>
-          </a:prstGeom>
-          <a:solidFill>
-            <a:srgbClr val="DDE3FA"/>
-          </a:solidFill>
-          <a:ln w="28575">
-            <a:solidFill>
-              <a:srgbClr val="1F3FD1"/>
-            </a:solidFill>
-            <a:prstDash val="solid"/>
-          </a:ln>
-        </p:spPr>
-      </p:sp>
-      <p:sp>
-        <p:nvSpPr>
-          <p:cNvPr id="8" name="Shape 6"/>
-          <p:cNvSpPr/>
-          <p:nvPr/>
-        </p:nvSpPr>
-        <p:spPr>
-          <a:xfrm>
-            <a:off x="6515100" y="5429250"/>
-            <a:ext cx="5257800" cy="1905000"/>
-          </a:xfrm>
-          <a:prstGeom prst="roundRect">
-            <a:avLst>
-              <a:gd name="adj" fmla="val 14000"/>
-            </a:avLst>
-          </a:prstGeom>
-          <a:solidFill>
-            <a:srgbClr val="DDE3FA"/>
-          </a:solidFill>
-          <a:ln w="28575">
-            <a:solidFill>
-              <a:srgbClr val="1F3FD1"/>
-            </a:solidFill>
-            <a:prstDash val="solid"/>
-          </a:ln>
-        </p:spPr>
-      </p:sp>
-      <p:sp>
-        <p:nvSpPr>
-          <p:cNvPr id="9" name="Shape 7"/>
-          <p:cNvSpPr/>
-          <p:nvPr/>
-        </p:nvSpPr>
-        <p:spPr>
-          <a:xfrm>
-            <a:off x="12115800" y="5429250"/>
-            <a:ext cx="5257800" cy="1905000"/>
-          </a:xfrm>
-          <a:prstGeom prst="roundRect">
-            <a:avLst>
-              <a:gd name="adj" fmla="val 14000"/>
-            </a:avLst>
-          </a:prstGeom>
-          <a:solidFill>
-            <a:srgbClr val="DDE3FA"/>
-          </a:solidFill>
-          <a:ln w="28575">
-            <a:solidFill>
-              <a:srgbClr val="1F3FD1"/>
-            </a:solidFill>
-            <a:prstDash val="solid"/>
-          </a:ln>
-        </p:spPr>
-      </p:sp>
-      <p:sp>
-        <p:nvSpPr>
-          <p:cNvPr id="10" name="Text 8"/>
+          <p:cNvPr id="6" name="Text 4"/>
           <p:cNvSpPr/>
           <p:nvPr/>
         </p:nvSpPr>
         <p:spPr>
           <a:xfrm>
             <a:off x="914400" y="3143250"/>
-            <a:ext cx="5257800" cy="1905000"/>
+            <a:ext cx="8001000" cy="1905000"/>
           </a:xfrm>
           <a:prstGeom prst="rect">
             <a:avLst/>
@@ -6654,7 +6546,7 @@
               <a:buNone/>
             </a:pPr>
             <a:r>
-              <a:rPr lang="en-US" sz="3450" dirty="0" spc="-37" kern="0">
+              <a:rPr lang="en-US" sz="3450" dirty="0" spc="3" kern="0">
                 <a:solidFill>
                   <a:srgbClr val="14161C"/>
                 </a:solidFill>
@@ -6662,7 +6554,29 @@
                 <a:ea typeface="Be Vietnam Pro ExtraBold" pitchFamily="34" charset="-122"/>
                 <a:cs typeface="Be Vietnam Pro ExtraBold" pitchFamily="34" charset="-120"/>
               </a:rPr>
-              <a:t>Pod</a:t>
+              <a:t>Bạn</a:t>
+            </a:r>
+            <a:r>
+              <a:rPr lang="en-US" sz="3450" dirty="0" spc="1" kern="0">
+                <a:solidFill>
+                  <a:srgbClr val="14161C"/>
+                </a:solidFill>
+                <a:latin typeface="Be Vietnam Pro ExtraBold" pitchFamily="34" charset="0"/>
+                <a:ea typeface="Be Vietnam Pro ExtraBold" pitchFamily="34" charset="-122"/>
+                <a:cs typeface="Be Vietnam Pro ExtraBold" pitchFamily="34" charset="-120"/>
+              </a:rPr>
+              <a:t> khai</a:t>
+            </a:r>
+            <a:r>
+              <a:rPr lang="en-US" sz="3450" dirty="0" spc="3" kern="0">
+                <a:solidFill>
+                  <a:srgbClr val="14161C"/>
+                </a:solidFill>
+                <a:latin typeface="Be Vietnam Pro ExtraBold" pitchFamily="34" charset="0"/>
+                <a:ea typeface="Be Vietnam Pro ExtraBold" pitchFamily="34" charset="-122"/>
+                <a:cs typeface="Be Vietnam Pro ExtraBold" pitchFamily="34" charset="-120"/>
+              </a:rPr>
+              <a:t> báo</a:t>
             </a:r>
             <a:endParaRPr lang="en-US" sz="3450" dirty="0"/>
           </a:p>
@@ -6670,14 +6584,14 @@
       </p:sp>
       <p:sp>
         <p:nvSpPr>
-          <p:cNvPr id="11" name="Text 9"/>
-          <p:cNvSpPr/>
-          <p:nvPr/>
-        </p:nvSpPr>
-        <p:spPr>
-          <a:xfrm>
-            <a:off x="6515100" y="3143250"/>
-            <a:ext cx="5257800" cy="1905000"/>
+          <p:cNvPr id="7" name="Text 5"/>
+          <p:cNvSpPr/>
+          <p:nvPr/>
+        </p:nvSpPr>
+        <p:spPr>
+          <a:xfrm>
+            <a:off x="9372600" y="3143250"/>
+            <a:ext cx="8001000" cy="1905000"/>
           </a:xfrm>
           <a:prstGeom prst="rect">
             <a:avLst/>
@@ -6693,7 +6607,7 @@
               <a:buNone/>
             </a:pPr>
             <a:r>
-              <a:rPr lang="en-US" sz="3450" dirty="0" spc="-26" kern="0">
+              <a:rPr lang="en-US" sz="3450" dirty="0" spc="-6" kern="0">
                 <a:solidFill>
                   <a:srgbClr val="14161C"/>
                 </a:solidFill>
@@ -6701,7 +6615,62 @@
                 <a:ea typeface="Be Vietnam Pro ExtraBold" pitchFamily="34" charset="-122"/>
                 <a:cs typeface="Be Vietnam Pro ExtraBold" pitchFamily="34" charset="-120"/>
               </a:rPr>
-              <a:t>Deployment</a:t>
+              <a:t>Nắm cùng</a:t>
+            </a:r>
+            <a:r>
+              <a:rPr lang="en-US" sz="3450" dirty="0" spc="-5" kern="0">
+                <a:solidFill>
+                  <a:srgbClr val="14161C"/>
+                </a:solidFill>
+                <a:latin typeface="Be Vietnam Pro ExtraBold" pitchFamily="34" charset="0"/>
+                <a:ea typeface="Be Vietnam Pro ExtraBold" pitchFamily="34" charset="-122"/>
+                <a:cs typeface="Be Vietnam Pro ExtraBold" pitchFamily="34" charset="-120"/>
+              </a:rPr>
+              <a:t> lõi,</a:t>
+            </a:r>
+            <a:r>
+              <a:rPr lang="en-US" sz="3450" dirty="0" spc="14" kern="0">
+                <a:solidFill>
+                  <a:srgbClr val="14161C"/>
+                </a:solidFill>
+                <a:latin typeface="Be Vietnam Pro ExtraBold" pitchFamily="34" charset="0"/>
+                <a:ea typeface="Be Vietnam Pro ExtraBold" pitchFamily="34" charset="-122"/>
+                <a:cs typeface="Be Vietnam Pro ExtraBold" pitchFamily="34" charset="-120"/>
+              </a:rPr>
+              <a:t> trước</a:t>
+            </a:r>
+            <a:r>
+              <a:rPr lang="en-US" sz="3450" dirty="0" spc="-4" kern="0">
+                <a:solidFill>
+                  <a:srgbClr val="14161C"/>
+                </a:solidFill>
+                <a:latin typeface="Be Vietnam Pro ExtraBold" pitchFamily="34" charset="0"/>
+                <a:ea typeface="Be Vietnam Pro ExtraBold" pitchFamily="34" charset="-122"/>
+                <a:cs typeface="Be Vietnam Pro ExtraBold" pitchFamily="34" charset="-120"/>
+              </a:rPr>
+              <a:t> hệ</a:t>
+            </a:r>
+            <a:r>
+              <a:rPr lang="en-US" sz="3450" dirty="0" spc="1" kern="0">
+                <a:solidFill>
+                  <a:srgbClr val="14161C"/>
+                </a:solidFill>
+                <a:latin typeface="Be Vietnam Pro ExtraBold" pitchFamily="34" charset="0"/>
+                <a:ea typeface="Be Vietnam Pro ExtraBold" pitchFamily="34" charset="-122"/>
+                <a:cs typeface="Be Vietnam Pro ExtraBold" pitchFamily="34" charset="-120"/>
+              </a:rPr>
+              <a:t> sinh</a:t>
+            </a:r>
+            <a:r>
+              <a:rPr lang="en-US" sz="3450" dirty="0" spc="0" kern="0">
+                <a:solidFill>
+                  <a:srgbClr val="14161C"/>
+                </a:solidFill>
+                <a:latin typeface="Be Vietnam Pro ExtraBold" pitchFamily="34" charset="0"/>
+                <a:ea typeface="Be Vietnam Pro ExtraBold" pitchFamily="34" charset="-122"/>
+                <a:cs typeface="Be Vietnam Pro ExtraBold" pitchFamily="34" charset="-120"/>
+              </a:rPr>
+              <a:t> thái</a:t>
             </a:r>
             <a:endParaRPr lang="en-US" sz="3450" dirty="0"/>
           </a:p>
@@ -6709,163 +6678,7 @@
       </p:sp>
       <p:sp>
         <p:nvSpPr>
-          <p:cNvPr id="12" name="Text 10"/>
-          <p:cNvSpPr/>
-          <p:nvPr/>
-        </p:nvSpPr>
-        <p:spPr>
-          <a:xfrm>
-            <a:off x="12115800" y="3143250"/>
-            <a:ext cx="5257800" cy="1905000"/>
-          </a:xfrm>
-          <a:prstGeom prst="rect">
-            <a:avLst/>
-          </a:prstGeom>
-          <a:noFill/>
-          <a:ln/>
-        </p:spPr>
-        <p:txBody>
-          <a:bodyPr wrap="square" lIns="0" tIns="0" rIns="0" bIns="0" rtlCol="0" anchor="ctr"/>
-          <a:lstStyle/>
-          <a:p>
-            <a:pPr algn="ctr" indent="0" marL="0">
-              <a:buNone/>
-            </a:pPr>
-            <a:r>
-              <a:rPr lang="en-US" sz="3450" dirty="0" spc="1" kern="0">
-                <a:solidFill>
-                  <a:srgbClr val="14161C"/>
-                </a:solidFill>
-                <a:latin typeface="Be Vietnam Pro ExtraBold" pitchFamily="34" charset="0"/>
-                <a:ea typeface="Be Vietnam Pro ExtraBold" pitchFamily="34" charset="-122"/>
-                <a:cs typeface="Be Vietnam Pro ExtraBold" pitchFamily="34" charset="-120"/>
-              </a:rPr>
-              <a:t>Service</a:t>
-            </a:r>
-            <a:endParaRPr lang="en-US" sz="3450" dirty="0"/>
-          </a:p>
-        </p:txBody>
-      </p:sp>
-      <p:sp>
-        <p:nvSpPr>
-          <p:cNvPr id="13" name="Text 11"/>
-          <p:cNvSpPr/>
-          <p:nvPr/>
-        </p:nvSpPr>
-        <p:spPr>
-          <a:xfrm>
-            <a:off x="914400" y="5429250"/>
-            <a:ext cx="5257800" cy="1905000"/>
-          </a:xfrm>
-          <a:prstGeom prst="rect">
-            <a:avLst/>
-          </a:prstGeom>
-          <a:noFill/>
-          <a:ln/>
-        </p:spPr>
-        <p:txBody>
-          <a:bodyPr wrap="square" lIns="0" tIns="0" rIns="0" bIns="0" rtlCol="0" anchor="ctr"/>
-          <a:lstStyle/>
-          <a:p>
-            <a:pPr algn="ctr" indent="0" marL="0">
-              <a:buNone/>
-            </a:pPr>
-            <a:r>
-              <a:rPr lang="en-US" sz="3450" dirty="0" spc="-4" kern="0">
-                <a:solidFill>
-                  <a:srgbClr val="14161C"/>
-                </a:solidFill>
-                <a:latin typeface="Be Vietnam Pro ExtraBold" pitchFamily="34" charset="0"/>
-                <a:ea typeface="Be Vietnam Pro ExtraBold" pitchFamily="34" charset="-122"/>
-                <a:cs typeface="Be Vietnam Pro ExtraBold" pitchFamily="34" charset="-120"/>
-              </a:rPr>
-              <a:t>ConfigMap</a:t>
-            </a:r>
-            <a:endParaRPr lang="en-US" sz="3450" dirty="0"/>
-          </a:p>
-        </p:txBody>
-      </p:sp>
-      <p:sp>
-        <p:nvSpPr>
-          <p:cNvPr id="14" name="Text 12"/>
-          <p:cNvSpPr/>
-          <p:nvPr/>
-        </p:nvSpPr>
-        <p:spPr>
-          <a:xfrm>
-            <a:off x="6515100" y="5429250"/>
-            <a:ext cx="5257800" cy="1905000"/>
-          </a:xfrm>
-          <a:prstGeom prst="rect">
-            <a:avLst/>
-          </a:prstGeom>
-          <a:noFill/>
-          <a:ln/>
-        </p:spPr>
-        <p:txBody>
-          <a:bodyPr wrap="square" lIns="0" tIns="0" rIns="0" bIns="0" rtlCol="0" anchor="ctr"/>
-          <a:lstStyle/>
-          <a:p>
-            <a:pPr algn="ctr" indent="0" marL="0">
-              <a:buNone/>
-            </a:pPr>
-            <a:r>
-              <a:rPr lang="en-US" sz="3450" dirty="0" spc="-18" kern="0">
-                <a:solidFill>
-                  <a:srgbClr val="14161C"/>
-                </a:solidFill>
-                <a:latin typeface="Be Vietnam Pro ExtraBold" pitchFamily="34" charset="0"/>
-                <a:ea typeface="Be Vietnam Pro ExtraBold" pitchFamily="34" charset="-122"/>
-                <a:cs typeface="Be Vietnam Pro ExtraBold" pitchFamily="34" charset="-120"/>
-              </a:rPr>
-              <a:t>Secret</a:t>
-            </a:r>
-            <a:endParaRPr lang="en-US" sz="3450" dirty="0"/>
-          </a:p>
-        </p:txBody>
-      </p:sp>
-      <p:sp>
-        <p:nvSpPr>
-          <p:cNvPr id="15" name="Text 13"/>
-          <p:cNvSpPr/>
-          <p:nvPr/>
-        </p:nvSpPr>
-        <p:spPr>
-          <a:xfrm>
-            <a:off x="12115800" y="5429250"/>
-            <a:ext cx="5257800" cy="1905000"/>
-          </a:xfrm>
-          <a:prstGeom prst="rect">
-            <a:avLst/>
-          </a:prstGeom>
-          <a:noFill/>
-          <a:ln/>
-        </p:spPr>
-        <p:txBody>
-          <a:bodyPr wrap="square" lIns="0" tIns="0" rIns="0" bIns="0" rtlCol="0" anchor="ctr"/>
-          <a:lstStyle/>
-          <a:p>
-            <a:pPr algn="ctr" indent="0" marL="0">
-              <a:buNone/>
-            </a:pPr>
-            <a:r>
-              <a:rPr lang="en-US" sz="3450" dirty="0" spc="-18" kern="0">
-                <a:solidFill>
-                  <a:srgbClr val="14161C"/>
-                </a:solidFill>
-                <a:latin typeface="Be Vietnam Pro ExtraBold" pitchFamily="34" charset="0"/>
-                <a:ea typeface="Be Vietnam Pro ExtraBold" pitchFamily="34" charset="-122"/>
-                <a:cs typeface="Be Vietnam Pro ExtraBold" pitchFamily="34" charset="-120"/>
-              </a:rPr>
-              <a:t>Ingress</a:t>
-            </a:r>
-            <a:endParaRPr lang="en-US" sz="3450" dirty="0"/>
-          </a:p>
-        </p:txBody>
-      </p:sp>
-      <p:sp>
-        <p:nvSpPr>
-          <p:cNvPr id="16" name="Text 14"/>
+          <p:cNvPr id="8" name="Text 6"/>
           <p:cNvSpPr/>
           <p:nvPr/>
         </p:nvSpPr>
@@ -6981,7 +6794,7 @@
       </p:sp>
       <p:sp>
         <p:nvSpPr>
-          <p:cNvPr id="17" name="Shape 15"/>
+          <p:cNvPr id="9" name="Shape 7"/>
           <p:cNvSpPr/>
           <p:nvPr/>
         </p:nvSpPr>
@@ -7001,7 +6814,7 @@
       </p:sp>
       <p:sp>
         <p:nvSpPr>
-          <p:cNvPr id="18" name="Shape 16"/>
+          <p:cNvPr id="10" name="Shape 8"/>
           <p:cNvSpPr/>
           <p:nvPr/>
         </p:nvSpPr>
@@ -7021,7 +6834,7 @@
       </p:sp>
       <p:sp>
         <p:nvSpPr>
-          <p:cNvPr id="19" name="Shape 17"/>
+          <p:cNvPr id="11" name="Shape 9"/>
           <p:cNvSpPr/>
           <p:nvPr/>
         </p:nvSpPr>
@@ -7041,7 +6854,7 @@
       </p:sp>
       <p:sp>
         <p:nvSpPr>
-          <p:cNvPr id="20" name="Shape 18"/>
+          <p:cNvPr id="12" name="Shape 10"/>
           <p:cNvSpPr/>
           <p:nvPr/>
         </p:nvSpPr>
@@ -7061,7 +6874,7 @@
       </p:sp>
       <p:sp>
         <p:nvSpPr>
-          <p:cNvPr id="21" name="Shape 19"/>
+          <p:cNvPr id="13" name="Shape 11"/>
           <p:cNvSpPr/>
           <p:nvPr/>
         </p:nvSpPr>
@@ -7081,7 +6894,7 @@
       </p:sp>
       <p:sp>
         <p:nvSpPr>
-          <p:cNvPr id="22" name="Shape 20"/>
+          <p:cNvPr id="14" name="Shape 12"/>
           <p:cNvSpPr/>
           <p:nvPr/>
         </p:nvSpPr>
@@ -7101,7 +6914,7 @@
       </p:sp>
       <p:sp>
         <p:nvSpPr>
-          <p:cNvPr id="23" name="Shape 21"/>
+          <p:cNvPr id="15" name="Shape 13"/>
           <p:cNvSpPr/>
           <p:nvPr/>
         </p:nvSpPr>
@@ -7121,7 +6934,7 @@
       </p:sp>
       <p:sp>
         <p:nvSpPr>
-          <p:cNvPr id="24" name="Shape 22"/>
+          <p:cNvPr id="16" name="Shape 14"/>
           <p:cNvSpPr/>
           <p:nvPr/>
         </p:nvSpPr>
@@ -7141,7 +6954,7 @@
       </p:sp>
       <p:sp>
         <p:nvSpPr>
-          <p:cNvPr id="25" name="Shape 23"/>
+          <p:cNvPr id="17" name="Shape 15"/>
           <p:cNvSpPr/>
           <p:nvPr/>
         </p:nvSpPr>
@@ -7161,7 +6974,7 @@
       </p:sp>
       <p:sp>
         <p:nvSpPr>
-          <p:cNvPr id="26" name="Shape 24"/>
+          <p:cNvPr id="18" name="Shape 16"/>
           <p:cNvSpPr/>
           <p:nvPr/>
         </p:nvSpPr>
@@ -7181,7 +6994,7 @@
       </p:sp>
       <p:sp>
         <p:nvSpPr>
-          <p:cNvPr id="27" name="Text 25"/>
+          <p:cNvPr id="19" name="Text 17"/>
           <p:cNvSpPr/>
           <p:nvPr/>
         </p:nvSpPr>
@@ -7297,7 +7110,7 @@
       </p:sp>
       <p:sp>
         <p:nvSpPr>
-          <p:cNvPr id="28" name="Shape 26"/>
+          <p:cNvPr id="20" name="Shape 18"/>
           <p:cNvSpPr/>
           <p:nvPr/>
         </p:nvSpPr>
@@ -7321,7 +7134,7 @@
       </p:sp>
       <p:pic>
         <p:nvPicPr>
-          <p:cNvPr id="29" name="Moda image moda-export-watermark-a7a498aa-1610-4e39-961a-1ca99389bf02" descr="">    </p:cNvPr>
+          <p:cNvPr id="21" name="Moda image moda-export-watermark-a7a498aa-1610-4e39-961a-1ca99389bf02" descr="">    </p:cNvPr>
           <p:cNvPicPr>
             <a:picLocks noChangeAspect="1"/>
           </p:cNvPicPr>

</xml_diff>